<commit_message>
Fix card and grid spacing in PowerPoint boilerplate
The stat-card grid was hand-positioned and overran the right page
margin by 0.55in while using mismatched gutters (0.32 horizontal,
0.25 vertical). Replaced with computed grid maths so the right column
lands exactly on the margin and both gutters are 0.3in.

The brand card grid used a 0.3in horizontal gutter against a 0.2in
vertical one. Unified to 0.3in in both directions and trimmed card
height so the bottom row keeps clear of the footer.

Co-Authored-By: Claude Opus 5 <noreply@anthropic.com>
Claude-Session: https://claude.ai/code/session_01SnogZdgM63RqNqKgBa95gN
</commit_message>
<xml_diff>
--- a/brand/powerpoint/LTV-Presentation-Boilerplate.pptx
+++ b/brand/powerpoint/LTV-Presentation-Boilerplate.pptx
@@ -10943,12 +10943,12 @@
         </p:nvSpPr>
         <p:spPr>
           <a:xfrm>
-            <a:off x="6263640" y="1783080"/>
-            <a:ext cx="2724912" cy="1691640"/>
+            <a:off x="6035040" y="1783080"/>
+            <a:ext cx="2598268" cy="1737360"/>
           </a:xfrm>
           <a:prstGeom prst="roundRect">
             <a:avLst>
-              <a:gd name="adj" fmla="val 6486"/>
+              <a:gd name="adj" fmla="val 6316"/>
             </a:avLst>
           </a:prstGeom>
           <a:solidFill>
@@ -10972,8 +10972,8 @@
         </p:nvSpPr>
         <p:spPr>
           <a:xfrm>
-            <a:off x="6519672" y="2130552"/>
-            <a:ext cx="2212848" cy="685800"/>
+            <a:off x="6309360" y="2148840"/>
+            <a:ext cx="2049628" cy="685800"/>
           </a:xfrm>
           <a:prstGeom prst="rect">
             <a:avLst/>
@@ -11011,8 +11011,8 @@
         </p:nvSpPr>
         <p:spPr>
           <a:xfrm>
-            <a:off x="6519672" y="2843784"/>
-            <a:ext cx="2212848" cy="274320"/>
+            <a:off x="6309360" y="2880360"/>
+            <a:ext cx="2049628" cy="274320"/>
           </a:xfrm>
           <a:prstGeom prst="rect">
             <a:avLst/>
@@ -11050,12 +11050,12 @@
         </p:nvSpPr>
         <p:spPr>
           <a:xfrm>
-            <a:off x="9281160" y="1783080"/>
-            <a:ext cx="2724912" cy="1691640"/>
+            <a:off x="8907628" y="1783080"/>
+            <a:ext cx="2598268" cy="1737360"/>
           </a:xfrm>
           <a:prstGeom prst="roundRect">
             <a:avLst>
-              <a:gd name="adj" fmla="val 6486"/>
+              <a:gd name="adj" fmla="val 6316"/>
             </a:avLst>
           </a:prstGeom>
           <a:solidFill>
@@ -11079,8 +11079,8 @@
         </p:nvSpPr>
         <p:spPr>
           <a:xfrm>
-            <a:off x="9537192" y="2130552"/>
-            <a:ext cx="2212848" cy="685800"/>
+            <a:off x="9181948" y="2148840"/>
+            <a:ext cx="2049628" cy="685800"/>
           </a:xfrm>
           <a:prstGeom prst="rect">
             <a:avLst/>
@@ -11118,8 +11118,8 @@
         </p:nvSpPr>
         <p:spPr>
           <a:xfrm>
-            <a:off x="9537192" y="2843784"/>
-            <a:ext cx="2212848" cy="274320"/>
+            <a:off x="9181948" y="2880360"/>
+            <a:ext cx="2049628" cy="274320"/>
           </a:xfrm>
           <a:prstGeom prst="rect">
             <a:avLst/>
@@ -11157,12 +11157,12 @@
         </p:nvSpPr>
         <p:spPr>
           <a:xfrm>
-            <a:off x="6263640" y="3703320"/>
-            <a:ext cx="2724912" cy="1691640"/>
+            <a:off x="6035040" y="3794760"/>
+            <a:ext cx="2598268" cy="1737360"/>
           </a:xfrm>
           <a:prstGeom prst="roundRect">
             <a:avLst>
-              <a:gd name="adj" fmla="val 6486"/>
+              <a:gd name="adj" fmla="val 6316"/>
             </a:avLst>
           </a:prstGeom>
           <a:solidFill>
@@ -11186,8 +11186,8 @@
         </p:nvSpPr>
         <p:spPr>
           <a:xfrm>
-            <a:off x="6519672" y="4050792"/>
-            <a:ext cx="2212848" cy="685800"/>
+            <a:off x="6309360" y="4160520"/>
+            <a:ext cx="2049628" cy="685800"/>
           </a:xfrm>
           <a:prstGeom prst="rect">
             <a:avLst/>
@@ -11225,8 +11225,8 @@
         </p:nvSpPr>
         <p:spPr>
           <a:xfrm>
-            <a:off x="6519672" y="4764024"/>
-            <a:ext cx="2212848" cy="274320"/>
+            <a:off x="6309360" y="4892040"/>
+            <a:ext cx="2049628" cy="274320"/>
           </a:xfrm>
           <a:prstGeom prst="rect">
             <a:avLst/>
@@ -11264,12 +11264,12 @@
         </p:nvSpPr>
         <p:spPr>
           <a:xfrm>
-            <a:off x="9281160" y="3703320"/>
-            <a:ext cx="2724912" cy="1691640"/>
+            <a:off x="8907628" y="3794760"/>
+            <a:ext cx="2598268" cy="1737360"/>
           </a:xfrm>
           <a:prstGeom prst="roundRect">
             <a:avLst>
-              <a:gd name="adj" fmla="val 6486"/>
+              <a:gd name="adj" fmla="val 6316"/>
             </a:avLst>
           </a:prstGeom>
           <a:solidFill>
@@ -11293,8 +11293,8 @@
         </p:nvSpPr>
         <p:spPr>
           <a:xfrm>
-            <a:off x="9537192" y="4050792"/>
-            <a:ext cx="2212848" cy="685800"/>
+            <a:off x="9181948" y="4160520"/>
+            <a:ext cx="2049628" cy="685800"/>
           </a:xfrm>
           <a:prstGeom prst="rect">
             <a:avLst/>
@@ -11332,8 +11332,8 @@
         </p:nvSpPr>
         <p:spPr>
           <a:xfrm>
-            <a:off x="9537192" y="4764024"/>
-            <a:ext cx="2212848" cy="274320"/>
+            <a:off x="9181948" y="4892040"/>
+            <a:ext cx="2049628" cy="274320"/>
           </a:xfrm>
           <a:prstGeom prst="rect">
             <a:avLst/>
@@ -11521,11 +11521,11 @@
         <p:spPr>
           <a:xfrm>
             <a:off x="685800" y="2148840"/>
-            <a:ext cx="3423818" cy="1143000"/>
+            <a:ext cx="3423818" cy="1097280"/>
           </a:xfrm>
           <a:prstGeom prst="roundRect">
             <a:avLst>
-              <a:gd name="adj" fmla="val 9600"/>
+              <a:gd name="adj" fmla="val 10000"/>
             </a:avLst>
           </a:prstGeom>
           <a:solidFill>
@@ -11554,7 +11554,7 @@
         </p:nvSpPr>
         <p:spPr>
           <a:xfrm>
-            <a:off x="960120" y="2487168"/>
+            <a:off x="960120" y="2468880"/>
             <a:ext cx="457200" cy="457200"/>
           </a:xfrm>
           <a:prstGeom prst="ellipse">
@@ -11582,7 +11582,7 @@
         </p:blipFill>
         <p:spPr>
           <a:xfrm>
-            <a:off x="1088136" y="2615184"/>
+            <a:off x="1088136" y="2596896"/>
             <a:ext cx="201168" cy="201168"/>
           </a:xfrm>
           <a:prstGeom prst="rect">
@@ -11598,8 +11598,8 @@
         </p:nvSpPr>
         <p:spPr>
           <a:xfrm>
-            <a:off x="1554480" y="2459736"/>
-            <a:ext cx="2326538" cy="274320"/>
+            <a:off x="1554480" y="2441448"/>
+            <a:ext cx="2280818" cy="274320"/>
           </a:xfrm>
           <a:prstGeom prst="rect">
             <a:avLst/>
@@ -11637,8 +11637,8 @@
         </p:nvSpPr>
         <p:spPr>
           <a:xfrm>
-            <a:off x="1554480" y="2724912"/>
-            <a:ext cx="2326538" cy="237744"/>
+            <a:off x="1554480" y="2706624"/>
+            <a:ext cx="2280818" cy="237744"/>
           </a:xfrm>
           <a:prstGeom prst="rect">
             <a:avLst/>
@@ -11677,11 +11677,11 @@
         <p:spPr>
           <a:xfrm>
             <a:off x="4383938" y="2148840"/>
-            <a:ext cx="3423818" cy="1143000"/>
+            <a:ext cx="3423818" cy="1097280"/>
           </a:xfrm>
           <a:prstGeom prst="roundRect">
             <a:avLst>
-              <a:gd name="adj" fmla="val 9600"/>
+              <a:gd name="adj" fmla="val 10000"/>
             </a:avLst>
           </a:prstGeom>
           <a:solidFill>
@@ -11710,7 +11710,7 @@
         </p:nvSpPr>
         <p:spPr>
           <a:xfrm>
-            <a:off x="4658258" y="2487168"/>
+            <a:off x="4658258" y="2468880"/>
             <a:ext cx="457200" cy="457200"/>
           </a:xfrm>
           <a:prstGeom prst="ellipse">
@@ -11738,7 +11738,7 @@
         </p:blipFill>
         <p:spPr>
           <a:xfrm>
-            <a:off x="4786274" y="2615184"/>
+            <a:off x="4786274" y="2596896"/>
             <a:ext cx="201168" cy="201168"/>
           </a:xfrm>
           <a:prstGeom prst="rect">
@@ -11754,8 +11754,8 @@
         </p:nvSpPr>
         <p:spPr>
           <a:xfrm>
-            <a:off x="5252618" y="2459736"/>
-            <a:ext cx="2326538" cy="274320"/>
+            <a:off x="5252618" y="2441448"/>
+            <a:ext cx="2280818" cy="274320"/>
           </a:xfrm>
           <a:prstGeom prst="rect">
             <a:avLst/>
@@ -11793,8 +11793,8 @@
         </p:nvSpPr>
         <p:spPr>
           <a:xfrm>
-            <a:off x="5252618" y="2724912"/>
-            <a:ext cx="2326538" cy="237744"/>
+            <a:off x="5252618" y="2706624"/>
+            <a:ext cx="2280818" cy="237744"/>
           </a:xfrm>
           <a:prstGeom prst="rect">
             <a:avLst/>
@@ -11833,11 +11833,11 @@
         <p:spPr>
           <a:xfrm>
             <a:off x="8082077" y="2148840"/>
-            <a:ext cx="3423818" cy="1143000"/>
+            <a:ext cx="3423818" cy="1097280"/>
           </a:xfrm>
           <a:prstGeom prst="roundRect">
             <a:avLst>
-              <a:gd name="adj" fmla="val 9600"/>
+              <a:gd name="adj" fmla="val 10000"/>
             </a:avLst>
           </a:prstGeom>
           <a:solidFill>
@@ -11866,7 +11866,7 @@
         </p:nvSpPr>
         <p:spPr>
           <a:xfrm>
-            <a:off x="8356397" y="2487168"/>
+            <a:off x="8356397" y="2468880"/>
             <a:ext cx="457200" cy="457200"/>
           </a:xfrm>
           <a:prstGeom prst="ellipse">
@@ -11894,7 +11894,7 @@
         </p:blipFill>
         <p:spPr>
           <a:xfrm>
-            <a:off x="8484413" y="2615184"/>
+            <a:off x="8484413" y="2596896"/>
             <a:ext cx="201168" cy="201168"/>
           </a:xfrm>
           <a:prstGeom prst="rect">
@@ -11910,8 +11910,8 @@
         </p:nvSpPr>
         <p:spPr>
           <a:xfrm>
-            <a:off x="8950757" y="2459736"/>
-            <a:ext cx="2326538" cy="274320"/>
+            <a:off x="8950757" y="2441448"/>
+            <a:ext cx="2280818" cy="274320"/>
           </a:xfrm>
           <a:prstGeom prst="rect">
             <a:avLst/>
@@ -11949,8 +11949,8 @@
         </p:nvSpPr>
         <p:spPr>
           <a:xfrm>
-            <a:off x="8950757" y="2724912"/>
-            <a:ext cx="2326538" cy="237744"/>
+            <a:off x="8950757" y="2706624"/>
+            <a:ext cx="2280818" cy="237744"/>
           </a:xfrm>
           <a:prstGeom prst="rect">
             <a:avLst/>
@@ -11988,12 +11988,12 @@
         </p:nvSpPr>
         <p:spPr>
           <a:xfrm>
-            <a:off x="685800" y="3474720"/>
-            <a:ext cx="3423818" cy="1143000"/>
+            <a:off x="685800" y="3520440"/>
+            <a:ext cx="3423818" cy="1097280"/>
           </a:xfrm>
           <a:prstGeom prst="roundRect">
             <a:avLst>
-              <a:gd name="adj" fmla="val 9600"/>
+              <a:gd name="adj" fmla="val 10000"/>
             </a:avLst>
           </a:prstGeom>
           <a:solidFill>
@@ -12022,7 +12022,7 @@
         </p:nvSpPr>
         <p:spPr>
           <a:xfrm>
-            <a:off x="960120" y="3813048"/>
+            <a:off x="960120" y="3840480"/>
             <a:ext cx="457200" cy="457200"/>
           </a:xfrm>
           <a:prstGeom prst="ellipse">
@@ -12050,7 +12050,7 @@
         </p:blipFill>
         <p:spPr>
           <a:xfrm>
-            <a:off x="1088136" y="3941064"/>
+            <a:off x="1088136" y="3968496"/>
             <a:ext cx="201168" cy="201168"/>
           </a:xfrm>
           <a:prstGeom prst="rect">
@@ -12066,8 +12066,8 @@
         </p:nvSpPr>
         <p:spPr>
           <a:xfrm>
-            <a:off x="1554480" y="3785616"/>
-            <a:ext cx="2326538" cy="274320"/>
+            <a:off x="1554480" y="3813048"/>
+            <a:ext cx="2280818" cy="274320"/>
           </a:xfrm>
           <a:prstGeom prst="rect">
             <a:avLst/>
@@ -12105,8 +12105,8 @@
         </p:nvSpPr>
         <p:spPr>
           <a:xfrm>
-            <a:off x="1554480" y="4050792"/>
-            <a:ext cx="2326538" cy="237744"/>
+            <a:off x="1554480" y="4078224"/>
+            <a:ext cx="2280818" cy="237744"/>
           </a:xfrm>
           <a:prstGeom prst="rect">
             <a:avLst/>
@@ -12144,12 +12144,12 @@
         </p:nvSpPr>
         <p:spPr>
           <a:xfrm>
-            <a:off x="4383938" y="3474720"/>
-            <a:ext cx="3423818" cy="1143000"/>
+            <a:off x="4383938" y="3520440"/>
+            <a:ext cx="3423818" cy="1097280"/>
           </a:xfrm>
           <a:prstGeom prst="roundRect">
             <a:avLst>
-              <a:gd name="adj" fmla="val 9600"/>
+              <a:gd name="adj" fmla="val 10000"/>
             </a:avLst>
           </a:prstGeom>
           <a:solidFill>
@@ -12178,7 +12178,7 @@
         </p:nvSpPr>
         <p:spPr>
           <a:xfrm>
-            <a:off x="4658258" y="3813048"/>
+            <a:off x="4658258" y="3840480"/>
             <a:ext cx="457200" cy="457200"/>
           </a:xfrm>
           <a:prstGeom prst="ellipse">
@@ -12206,7 +12206,7 @@
         </p:blipFill>
         <p:spPr>
           <a:xfrm>
-            <a:off x="4786274" y="3941064"/>
+            <a:off x="4786274" y="3968496"/>
             <a:ext cx="201168" cy="201168"/>
           </a:xfrm>
           <a:prstGeom prst="rect">
@@ -12222,8 +12222,8 @@
         </p:nvSpPr>
         <p:spPr>
           <a:xfrm>
-            <a:off x="5252618" y="3785616"/>
-            <a:ext cx="2326538" cy="274320"/>
+            <a:off x="5252618" y="3813048"/>
+            <a:ext cx="2280818" cy="274320"/>
           </a:xfrm>
           <a:prstGeom prst="rect">
             <a:avLst/>
@@ -12261,8 +12261,8 @@
         </p:nvSpPr>
         <p:spPr>
           <a:xfrm>
-            <a:off x="5252618" y="4050792"/>
-            <a:ext cx="2326538" cy="237744"/>
+            <a:off x="5252618" y="4078224"/>
+            <a:ext cx="2280818" cy="237744"/>
           </a:xfrm>
           <a:prstGeom prst="rect">
             <a:avLst/>
@@ -12300,12 +12300,12 @@
         </p:nvSpPr>
         <p:spPr>
           <a:xfrm>
-            <a:off x="8082077" y="3474720"/>
-            <a:ext cx="3423818" cy="1143000"/>
+            <a:off x="8082077" y="3520440"/>
+            <a:ext cx="3423818" cy="1097280"/>
           </a:xfrm>
           <a:prstGeom prst="roundRect">
             <a:avLst>
-              <a:gd name="adj" fmla="val 9600"/>
+              <a:gd name="adj" fmla="val 10000"/>
             </a:avLst>
           </a:prstGeom>
           <a:solidFill>
@@ -12334,7 +12334,7 @@
         </p:nvSpPr>
         <p:spPr>
           <a:xfrm>
-            <a:off x="8356397" y="3813048"/>
+            <a:off x="8356397" y="3840480"/>
             <a:ext cx="457200" cy="457200"/>
           </a:xfrm>
           <a:prstGeom prst="ellipse">
@@ -12362,7 +12362,7 @@
         </p:blipFill>
         <p:spPr>
           <a:xfrm>
-            <a:off x="8484413" y="3941064"/>
+            <a:off x="8484413" y="3968496"/>
             <a:ext cx="201168" cy="201168"/>
           </a:xfrm>
           <a:prstGeom prst="rect">
@@ -12378,8 +12378,8 @@
         </p:nvSpPr>
         <p:spPr>
           <a:xfrm>
-            <a:off x="8950757" y="3785616"/>
-            <a:ext cx="2326538" cy="274320"/>
+            <a:off x="8950757" y="3813048"/>
+            <a:ext cx="2280818" cy="274320"/>
           </a:xfrm>
           <a:prstGeom prst="rect">
             <a:avLst/>
@@ -12417,8 +12417,8 @@
         </p:nvSpPr>
         <p:spPr>
           <a:xfrm>
-            <a:off x="8950757" y="4050792"/>
-            <a:ext cx="2326538" cy="237744"/>
+            <a:off x="8950757" y="4078224"/>
+            <a:ext cx="2280818" cy="237744"/>
           </a:xfrm>
           <a:prstGeom prst="rect">
             <a:avLst/>
@@ -12456,12 +12456,12 @@
         </p:nvSpPr>
         <p:spPr>
           <a:xfrm>
-            <a:off x="685800" y="4800600"/>
-            <a:ext cx="3423818" cy="1143000"/>
+            <a:off x="685800" y="4892040"/>
+            <a:ext cx="3423818" cy="1097280"/>
           </a:xfrm>
           <a:prstGeom prst="roundRect">
             <a:avLst>
-              <a:gd name="adj" fmla="val 9600"/>
+              <a:gd name="adj" fmla="val 10000"/>
             </a:avLst>
           </a:prstGeom>
           <a:solidFill>
@@ -12490,7 +12490,7 @@
         </p:nvSpPr>
         <p:spPr>
           <a:xfrm>
-            <a:off x="960120" y="5138928"/>
+            <a:off x="960120" y="5212080"/>
             <a:ext cx="457200" cy="457200"/>
           </a:xfrm>
           <a:prstGeom prst="ellipse">
@@ -12518,7 +12518,7 @@
         </p:blipFill>
         <p:spPr>
           <a:xfrm>
-            <a:off x="1088136" y="5266944"/>
+            <a:off x="1088136" y="5340096"/>
             <a:ext cx="201168" cy="201168"/>
           </a:xfrm>
           <a:prstGeom prst="rect">
@@ -12534,8 +12534,8 @@
         </p:nvSpPr>
         <p:spPr>
           <a:xfrm>
-            <a:off x="1554480" y="5111496"/>
-            <a:ext cx="2326538" cy="274320"/>
+            <a:off x="1554480" y="5184648"/>
+            <a:ext cx="2280818" cy="274320"/>
           </a:xfrm>
           <a:prstGeom prst="rect">
             <a:avLst/>
@@ -12573,8 +12573,8 @@
         </p:nvSpPr>
         <p:spPr>
           <a:xfrm>
-            <a:off x="1554480" y="5376672"/>
-            <a:ext cx="2326538" cy="237744"/>
+            <a:off x="1554480" y="5449824"/>
+            <a:ext cx="2280818" cy="237744"/>
           </a:xfrm>
           <a:prstGeom prst="rect">
             <a:avLst/>
@@ -12612,12 +12612,12 @@
         </p:nvSpPr>
         <p:spPr>
           <a:xfrm>
-            <a:off x="4383938" y="4800600"/>
-            <a:ext cx="3423818" cy="1143000"/>
+            <a:off x="4383938" y="4892040"/>
+            <a:ext cx="3423818" cy="1097280"/>
           </a:xfrm>
           <a:prstGeom prst="roundRect">
             <a:avLst>
-              <a:gd name="adj" fmla="val 9600"/>
+              <a:gd name="adj" fmla="val 10000"/>
             </a:avLst>
           </a:prstGeom>
           <a:solidFill>
@@ -12646,7 +12646,7 @@
         </p:nvSpPr>
         <p:spPr>
           <a:xfrm>
-            <a:off x="4658258" y="5138928"/>
+            <a:off x="4658258" y="5212080"/>
             <a:ext cx="457200" cy="457200"/>
           </a:xfrm>
           <a:prstGeom prst="ellipse">
@@ -12674,7 +12674,7 @@
         </p:blipFill>
         <p:spPr>
           <a:xfrm>
-            <a:off x="4786274" y="5266944"/>
+            <a:off x="4786274" y="5340096"/>
             <a:ext cx="201168" cy="201168"/>
           </a:xfrm>
           <a:prstGeom prst="rect">
@@ -12690,8 +12690,8 @@
         </p:nvSpPr>
         <p:spPr>
           <a:xfrm>
-            <a:off x="5252618" y="5111496"/>
-            <a:ext cx="2326538" cy="274320"/>
+            <a:off x="5252618" y="5184648"/>
+            <a:ext cx="2280818" cy="274320"/>
           </a:xfrm>
           <a:prstGeom prst="rect">
             <a:avLst/>
@@ -12729,8 +12729,8 @@
         </p:nvSpPr>
         <p:spPr>
           <a:xfrm>
-            <a:off x="5252618" y="5376672"/>
-            <a:ext cx="2326538" cy="237744"/>
+            <a:off x="5252618" y="5449824"/>
+            <a:ext cx="2280818" cy="237744"/>
           </a:xfrm>
           <a:prstGeom prst="rect">
             <a:avLst/>
@@ -12768,12 +12768,12 @@
         </p:nvSpPr>
         <p:spPr>
           <a:xfrm>
-            <a:off x="8082077" y="4800600"/>
-            <a:ext cx="3423818" cy="1143000"/>
+            <a:off x="8082077" y="4892040"/>
+            <a:ext cx="3423818" cy="1097280"/>
           </a:xfrm>
           <a:prstGeom prst="roundRect">
             <a:avLst>
-              <a:gd name="adj" fmla="val 9600"/>
+              <a:gd name="adj" fmla="val 10000"/>
             </a:avLst>
           </a:prstGeom>
           <a:solidFill>
@@ -12802,7 +12802,7 @@
         </p:nvSpPr>
         <p:spPr>
           <a:xfrm>
-            <a:off x="8356397" y="5138928"/>
+            <a:off x="8356397" y="5212080"/>
             <a:ext cx="457200" cy="457200"/>
           </a:xfrm>
           <a:prstGeom prst="ellipse">
@@ -12830,7 +12830,7 @@
         </p:blipFill>
         <p:spPr>
           <a:xfrm>
-            <a:off x="8484413" y="5266944"/>
+            <a:off x="8484413" y="5340096"/>
             <a:ext cx="201168" cy="201168"/>
           </a:xfrm>
           <a:prstGeom prst="rect">
@@ -12846,8 +12846,8 @@
         </p:nvSpPr>
         <p:spPr>
           <a:xfrm>
-            <a:off x="8950757" y="5111496"/>
-            <a:ext cx="2326538" cy="274320"/>
+            <a:off x="8950757" y="5184648"/>
+            <a:ext cx="2280818" cy="274320"/>
           </a:xfrm>
           <a:prstGeom prst="rect">
             <a:avLst/>
@@ -12885,8 +12885,8 @@
         </p:nvSpPr>
         <p:spPr>
           <a:xfrm>
-            <a:off x="8950757" y="5376672"/>
-            <a:ext cx="2326538" cy="237744"/>
+            <a:off x="8950757" y="5449824"/>
+            <a:ext cx="2280818" cy="237744"/>
           </a:xfrm>
           <a:prstGeom prst="rect">
             <a:avLst/>

</xml_diff>